<commit_message>
Deck RDUE v3 : carte des pays par niveau de risque, sommaire sans minutage
- Carte choroplèthe générée hors ligne (world-atlas + d3-geo) d'après le règlement d'exécution 2025/1093, liste des pays à risque standard dans standard.json
- Slide 19 recomposée (cartes de risque à gauche, carte à droite, légende)
- Sommaire : suppression des durées par partie

Co-Authored-By: Claude Fable 5.1 <noreply@anthropic.com>
Claude-Session: https://claude.ai/code/session_01DKVSBXm2NFFqwp2PRsGeYJ
</commit_message>
<xml_diff>
--- a/webinaire-rdue-2026-09-24/RDUE_Webinaire_2026-09-24_v3.pptx
+++ b/webinaire-rdue-2026-09-24/RDUE_Webinaire_2026-09-24_v3.pptx
@@ -15106,11 +15106,11 @@
         <p:spPr>
           <a:xfrm>
             <a:off x="548640" y="1691640"/>
-            <a:ext cx="11064240" cy="1234440"/>
+            <a:ext cx="4754880" cy="1188720"/>
           </a:xfrm>
           <a:prstGeom prst="roundRect">
             <a:avLst>
-              <a:gd name="adj" fmla="val 5926"/>
+              <a:gd name="adj" fmla="val 6154"/>
             </a:avLst>
           </a:prstGeom>
           <a:solidFill>
@@ -15140,11 +15140,11 @@
         <p:spPr>
           <a:xfrm>
             <a:off x="548640" y="1691640"/>
-            <a:ext cx="2103120" cy="1234440"/>
+            <a:ext cx="1234440" cy="1188720"/>
           </a:xfrm>
           <a:prstGeom prst="roundRect">
             <a:avLst>
-              <a:gd name="adj" fmla="val 5926"/>
+              <a:gd name="adj" fmla="val 6154"/>
             </a:avLst>
           </a:prstGeom>
           <a:solidFill>
@@ -15166,8 +15166,8 @@
         </p:nvSpPr>
         <p:spPr>
           <a:xfrm>
-            <a:off x="2377440" y="1691640"/>
-            <a:ext cx="274320" cy="1234440"/>
+            <a:off x="1600200" y="1691640"/>
+            <a:ext cx="182880" cy="1188720"/>
           </a:xfrm>
           <a:prstGeom prst="rect">
             <a:avLst/>
@@ -15192,7 +15192,7 @@
         <p:spPr>
           <a:xfrm>
             <a:off x="548640" y="1801368"/>
-            <a:ext cx="2103120" cy="640080"/>
+            <a:ext cx="1234440" cy="594360"/>
           </a:xfrm>
           <a:prstGeom prst="rect">
             <a:avLst/>
@@ -15208,7 +15208,7 @@
               <a:buNone/>
             </a:pPr>
             <a:r>
-              <a:rPr lang="en-US" sz="3400" b="1" dirty="0">
+              <a:rPr lang="en-US" sz="2600" b="1" dirty="0">
                 <a:solidFill>
                   <a:srgbClr val="FFFFFF"/>
                 </a:solidFill>
@@ -15218,7 +15218,7 @@
               </a:rPr>
               <a:t>140</a:t>
             </a:r>
-            <a:endParaRPr lang="en-US" sz="3400" dirty="0"/>
+            <a:endParaRPr lang="en-US" sz="2600" dirty="0"/>
           </a:p>
         </p:txBody>
       </p:sp>
@@ -15230,8 +15230,8 @@
         </p:nvSpPr>
         <p:spPr>
           <a:xfrm>
-            <a:off x="548640" y="2468880"/>
-            <a:ext cx="2103120" cy="320040"/>
+            <a:off x="548640" y="2441448"/>
+            <a:ext cx="1234440" cy="320040"/>
           </a:xfrm>
           <a:prstGeom prst="rect">
             <a:avLst/>
@@ -15247,7 +15247,7 @@
               <a:buNone/>
             </a:pPr>
             <a:r>
-              <a:rPr lang="en-US" sz="1000" b="1" spc="150" kern="0" dirty="0">
+              <a:rPr lang="en-US" sz="800" b="1" spc="100" kern="0" dirty="0">
                 <a:solidFill>
                   <a:srgbClr val="FFFFFF"/>
                 </a:solidFill>
@@ -15257,7 +15257,7 @@
               </a:rPr>
               <a:t>RISQUE FAIBLE</a:t>
             </a:r>
-            <a:endParaRPr lang="en-US" sz="1000" dirty="0"/>
+            <a:endParaRPr lang="en-US" sz="800" dirty="0"/>
           </a:p>
         </p:txBody>
       </p:sp>
@@ -15269,8 +15269,8 @@
         </p:nvSpPr>
         <p:spPr>
           <a:xfrm>
-            <a:off x="2926080" y="1828800"/>
-            <a:ext cx="6035040" cy="365760"/>
+            <a:off x="1920240" y="1783080"/>
+            <a:ext cx="2651760" cy="548640"/>
           </a:xfrm>
           <a:prstGeom prst="rect">
             <a:avLst/>
@@ -15286,7 +15286,7 @@
               <a:buNone/>
             </a:pPr>
             <a:r>
-              <a:rPr lang="en-US" sz="1350" b="1" dirty="0">
+              <a:rPr lang="en-US" sz="1050" b="1" dirty="0">
                 <a:solidFill>
                   <a:srgbClr val="0A2A5E"/>
                 </a:solidFill>
@@ -15294,9 +15294,9 @@
                 <a:ea typeface="Calibri" pitchFamily="34" charset="-122"/>
                 <a:cs typeface="Calibri" pitchFamily="34" charset="-120"/>
               </a:rPr>
-              <a:t>pays, dont toute l'UE, le Royaume-Uni, les États-Unis, la Chine…</a:t>
-            </a:r>
-            <a:endParaRPr lang="en-US" sz="1350" dirty="0"/>
+              <a:t>pays, dont toute l'UE, le Royaume-Uni, les États-Unis, la Chine, l'Inde, le Vietnam…</a:t>
+            </a:r>
+            <a:endParaRPr lang="en-US" sz="1050" dirty="0"/>
           </a:p>
         </p:txBody>
       </p:sp>
@@ -15308,8 +15308,8 @@
         </p:nvSpPr>
         <p:spPr>
           <a:xfrm>
-            <a:off x="2926080" y="2240280"/>
-            <a:ext cx="6035040" cy="640080"/>
+            <a:off x="1920240" y="2350008"/>
+            <a:ext cx="2651760" cy="502920"/>
           </a:xfrm>
           <a:prstGeom prst="rect">
             <a:avLst/>
@@ -15325,7 +15325,7 @@
               <a:buNone/>
             </a:pPr>
             <a:r>
-              <a:rPr lang="en-US" sz="1200" dirty="0">
+              <a:rPr lang="en-US" sz="950" dirty="0">
                 <a:solidFill>
                   <a:srgbClr val="5B6B7F"/>
                 </a:solidFill>
@@ -15333,9 +15333,9 @@
                 <a:ea typeface="Calibri" pitchFamily="34" charset="-122"/>
                 <a:cs typeface="Calibri" pitchFamily="34" charset="-120"/>
               </a:rPr>
-              <a:t>Diligence simplifiée : seule la collecte d'informations (étape 1) est exigée — l'avantage stratégique.</a:t>
-            </a:r>
-            <a:endParaRPr lang="en-US" sz="1200" dirty="0"/>
+              <a:t>Diligence simplifiée : seule la collecte (étape 1) est exigée.</a:t>
+            </a:r>
+            <a:endParaRPr lang="en-US" sz="950" dirty="0"/>
           </a:p>
         </p:txBody>
       </p:sp>
@@ -15347,8 +15347,8 @@
         </p:nvSpPr>
         <p:spPr>
           <a:xfrm>
-            <a:off x="9418320" y="1874520"/>
-            <a:ext cx="2011680" cy="274320"/>
+            <a:off x="4617720" y="1874520"/>
+            <a:ext cx="640080" cy="228600"/>
           </a:xfrm>
           <a:prstGeom prst="rect">
             <a:avLst/>
@@ -15364,7 +15364,7 @@
               <a:buNone/>
             </a:pPr>
             <a:r>
-              <a:rPr lang="en-US" sz="1000" spc="150" kern="0" dirty="0">
+              <a:rPr lang="en-US" sz="800" dirty="0">
                 <a:solidFill>
                   <a:srgbClr val="8A98A8"/>
                 </a:solidFill>
@@ -15372,9 +15372,9 @@
                 <a:ea typeface="Calibri" pitchFamily="34" charset="-122"/>
                 <a:cs typeface="Calibri" pitchFamily="34" charset="-120"/>
               </a:rPr>
-              <a:t>Contrôles</a:t>
-            </a:r>
-            <a:endParaRPr lang="en-US" sz="1000" dirty="0"/>
+              <a:t>contrôles</a:t>
+            </a:r>
+            <a:endParaRPr lang="en-US" sz="800" dirty="0"/>
           </a:p>
         </p:txBody>
       </p:sp>
@@ -15386,8 +15386,8 @@
         </p:nvSpPr>
         <p:spPr>
           <a:xfrm>
-            <a:off x="9418320" y="2103120"/>
-            <a:ext cx="2011680" cy="640080"/>
+            <a:off x="4572000" y="2103120"/>
+            <a:ext cx="731520" cy="548640"/>
           </a:xfrm>
           <a:prstGeom prst="rect">
             <a:avLst/>
@@ -15403,7 +15403,7 @@
               <a:buNone/>
             </a:pPr>
             <a:r>
-              <a:rPr lang="en-US" sz="2600" b="1" dirty="0">
+              <a:rPr lang="en-US" sz="2000" b="1" dirty="0">
                 <a:solidFill>
                   <a:srgbClr val="1E8E5A"/>
                 </a:solidFill>
@@ -15413,7 +15413,7 @@
               </a:rPr>
               <a:t>1 %</a:t>
             </a:r>
-            <a:endParaRPr lang="en-US" sz="2600" dirty="0"/>
+            <a:endParaRPr lang="en-US" sz="2000" dirty="0"/>
           </a:p>
         </p:txBody>
       </p:sp>
@@ -15425,12 +15425,12 @@
         </p:nvSpPr>
         <p:spPr>
           <a:xfrm>
-            <a:off x="548640" y="3063240"/>
-            <a:ext cx="11064240" cy="1234440"/>
+            <a:off x="548640" y="3017520"/>
+            <a:ext cx="4754880" cy="1188720"/>
           </a:xfrm>
           <a:prstGeom prst="roundRect">
             <a:avLst>
-              <a:gd name="adj" fmla="val 5926"/>
+              <a:gd name="adj" fmla="val 6154"/>
             </a:avLst>
           </a:prstGeom>
           <a:solidFill>
@@ -15459,12 +15459,12 @@
         </p:nvSpPr>
         <p:spPr>
           <a:xfrm>
-            <a:off x="548640" y="3063240"/>
-            <a:ext cx="2103120" cy="1234440"/>
+            <a:off x="548640" y="3017520"/>
+            <a:ext cx="1234440" cy="1188720"/>
           </a:xfrm>
           <a:prstGeom prst="roundRect">
             <a:avLst>
-              <a:gd name="adj" fmla="val 5926"/>
+              <a:gd name="adj" fmla="val 6154"/>
             </a:avLst>
           </a:prstGeom>
           <a:solidFill>
@@ -15486,8 +15486,8 @@
         </p:nvSpPr>
         <p:spPr>
           <a:xfrm>
-            <a:off x="2377440" y="3063240"/>
-            <a:ext cx="274320" cy="1234440"/>
+            <a:off x="1600200" y="3017520"/>
+            <a:ext cx="182880" cy="1188720"/>
           </a:xfrm>
           <a:prstGeom prst="rect">
             <a:avLst/>
@@ -15511,8 +15511,8 @@
         </p:nvSpPr>
         <p:spPr>
           <a:xfrm>
-            <a:off x="548640" y="3172968"/>
-            <a:ext cx="2103120" cy="640080"/>
+            <a:off x="548640" y="3127248"/>
+            <a:ext cx="1234440" cy="594360"/>
           </a:xfrm>
           <a:prstGeom prst="rect">
             <a:avLst/>
@@ -15528,7 +15528,7 @@
               <a:buNone/>
             </a:pPr>
             <a:r>
-              <a:rPr lang="en-US" sz="3400" b="1" dirty="0">
+              <a:rPr lang="en-US" sz="2600" b="1" dirty="0">
                 <a:solidFill>
                   <a:srgbClr val="FFFFFF"/>
                 </a:solidFill>
@@ -15538,7 +15538,7 @@
               </a:rPr>
               <a:t>~50</a:t>
             </a:r>
-            <a:endParaRPr lang="en-US" sz="3400" dirty="0"/>
+            <a:endParaRPr lang="en-US" sz="2600" dirty="0"/>
           </a:p>
         </p:txBody>
       </p:sp>
@@ -15550,8 +15550,8 @@
         </p:nvSpPr>
         <p:spPr>
           <a:xfrm>
-            <a:off x="548640" y="3840480"/>
-            <a:ext cx="2103120" cy="320040"/>
+            <a:off x="548640" y="3767328"/>
+            <a:ext cx="1234440" cy="320040"/>
           </a:xfrm>
           <a:prstGeom prst="rect">
             <a:avLst/>
@@ -15567,7 +15567,7 @@
               <a:buNone/>
             </a:pPr>
             <a:r>
-              <a:rPr lang="en-US" sz="1000" b="1" spc="150" kern="0" dirty="0">
+              <a:rPr lang="en-US" sz="800" b="1" spc="100" kern="0" dirty="0">
                 <a:solidFill>
                   <a:srgbClr val="FFFFFF"/>
                 </a:solidFill>
@@ -15577,7 +15577,7 @@
               </a:rPr>
               <a:t>RISQUE STANDARD</a:t>
             </a:r>
-            <a:endParaRPr lang="en-US" sz="1000" dirty="0"/>
+            <a:endParaRPr lang="en-US" sz="800" dirty="0"/>
           </a:p>
         </p:txBody>
       </p:sp>
@@ -15589,8 +15589,8 @@
         </p:nvSpPr>
         <p:spPr>
           <a:xfrm>
-            <a:off x="2926080" y="3200400"/>
-            <a:ext cx="6035040" cy="365760"/>
+            <a:off x="1920240" y="3108960"/>
+            <a:ext cx="2651760" cy="548640"/>
           </a:xfrm>
           <a:prstGeom prst="rect">
             <a:avLst/>
@@ -15606,7 +15606,7 @@
               <a:buNone/>
             </a:pPr>
             <a:r>
-              <a:rPr lang="en-US" sz="1350" b="1" dirty="0">
+              <a:rPr lang="en-US" sz="1050" b="1" dirty="0">
                 <a:solidFill>
                   <a:srgbClr val="0A2A5E"/>
                 </a:solidFill>
@@ -15614,9 +15614,9 @@
                 <a:ea typeface="Calibri" pitchFamily="34" charset="-122"/>
                 <a:cs typeface="Calibri" pitchFamily="34" charset="-120"/>
               </a:rPr>
-              <a:t>pays — Brésil, Indonésie, Malaisie, Côte d'Ivoire…</a:t>
-            </a:r>
-            <a:endParaRPr lang="en-US" sz="1350" dirty="0"/>
+              <a:t>pays — Brésil, Indonésie, Malaisie, Côte d'Ivoire, Colombie, Pérou…</a:t>
+            </a:r>
+            <a:endParaRPr lang="en-US" sz="1050" dirty="0"/>
           </a:p>
         </p:txBody>
       </p:sp>
@@ -15628,8 +15628,8 @@
         </p:nvSpPr>
         <p:spPr>
           <a:xfrm>
-            <a:off x="2926080" y="3611880"/>
-            <a:ext cx="6035040" cy="640080"/>
+            <a:off x="1920240" y="3675888"/>
+            <a:ext cx="2651760" cy="502920"/>
           </a:xfrm>
           <a:prstGeom prst="rect">
             <a:avLst/>
@@ -15645,7 +15645,7 @@
               <a:buNone/>
             </a:pPr>
             <a:r>
-              <a:rPr lang="en-US" sz="1200" dirty="0">
+              <a:rPr lang="en-US" sz="950" dirty="0">
                 <a:solidFill>
                   <a:srgbClr val="5B6B7F"/>
                 </a:solidFill>
@@ -15653,9 +15653,9 @@
                 <a:ea typeface="Calibri" pitchFamily="34" charset="-122"/>
                 <a:cs typeface="Calibri" pitchFamily="34" charset="-120"/>
               </a:rPr>
-              <a:t>Diligence raisonnée complète : les trois étapes sont obligatoires.</a:t>
-            </a:r>
-            <a:endParaRPr lang="en-US" sz="1200" dirty="0"/>
+              <a:t>Diligence raisonnée complète : les trois étapes.</a:t>
+            </a:r>
+            <a:endParaRPr lang="en-US" sz="950" dirty="0"/>
           </a:p>
         </p:txBody>
       </p:sp>
@@ -15667,8 +15667,8 @@
         </p:nvSpPr>
         <p:spPr>
           <a:xfrm>
-            <a:off x="9418320" y="3246120"/>
-            <a:ext cx="2011680" cy="274320"/>
+            <a:off x="4617720" y="3200400"/>
+            <a:ext cx="640080" cy="228600"/>
           </a:xfrm>
           <a:prstGeom prst="rect">
             <a:avLst/>
@@ -15684,7 +15684,7 @@
               <a:buNone/>
             </a:pPr>
             <a:r>
-              <a:rPr lang="en-US" sz="1000" spc="150" kern="0" dirty="0">
+              <a:rPr lang="en-US" sz="800" dirty="0">
                 <a:solidFill>
                   <a:srgbClr val="8A98A8"/>
                 </a:solidFill>
@@ -15692,9 +15692,9 @@
                 <a:ea typeface="Calibri" pitchFamily="34" charset="-122"/>
                 <a:cs typeface="Calibri" pitchFamily="34" charset="-120"/>
               </a:rPr>
-              <a:t>Contrôles</a:t>
-            </a:r>
-            <a:endParaRPr lang="en-US" sz="1000" dirty="0"/>
+              <a:t>contrôles</a:t>
+            </a:r>
+            <a:endParaRPr lang="en-US" sz="800" dirty="0"/>
           </a:p>
         </p:txBody>
       </p:sp>
@@ -15706,8 +15706,8 @@
         </p:nvSpPr>
         <p:spPr>
           <a:xfrm>
-            <a:off x="9418320" y="3474720"/>
-            <a:ext cx="2011680" cy="640080"/>
+            <a:off x="4572000" y="3429000"/>
+            <a:ext cx="731520" cy="548640"/>
           </a:xfrm>
           <a:prstGeom prst="rect">
             <a:avLst/>
@@ -15723,7 +15723,7 @@
               <a:buNone/>
             </a:pPr>
             <a:r>
-              <a:rPr lang="en-US" sz="2600" b="1" dirty="0">
+              <a:rPr lang="en-US" sz="2000" b="1" dirty="0">
                 <a:solidFill>
                   <a:srgbClr val="B7791F"/>
                 </a:solidFill>
@@ -15733,7 +15733,7 @@
               </a:rPr>
               <a:t>3 %</a:t>
             </a:r>
-            <a:endParaRPr lang="en-US" sz="2600" dirty="0"/>
+            <a:endParaRPr lang="en-US" sz="2000" dirty="0"/>
           </a:p>
         </p:txBody>
       </p:sp>
@@ -15745,12 +15745,12 @@
         </p:nvSpPr>
         <p:spPr>
           <a:xfrm>
-            <a:off x="548640" y="4434840"/>
-            <a:ext cx="11064240" cy="1234440"/>
+            <a:off x="548640" y="4343400"/>
+            <a:ext cx="4754880" cy="1188720"/>
           </a:xfrm>
           <a:prstGeom prst="roundRect">
             <a:avLst>
-              <a:gd name="adj" fmla="val 5926"/>
+              <a:gd name="adj" fmla="val 6154"/>
             </a:avLst>
           </a:prstGeom>
           <a:solidFill>
@@ -15779,12 +15779,12 @@
         </p:nvSpPr>
         <p:spPr>
           <a:xfrm>
-            <a:off x="548640" y="4434840"/>
-            <a:ext cx="2103120" cy="1234440"/>
+            <a:off x="548640" y="4343400"/>
+            <a:ext cx="1234440" cy="1188720"/>
           </a:xfrm>
           <a:prstGeom prst="roundRect">
             <a:avLst>
-              <a:gd name="adj" fmla="val 5926"/>
+              <a:gd name="adj" fmla="val 6154"/>
             </a:avLst>
           </a:prstGeom>
           <a:solidFill>
@@ -15806,8 +15806,8 @@
         </p:nvSpPr>
         <p:spPr>
           <a:xfrm>
-            <a:off x="2377440" y="4434840"/>
-            <a:ext cx="274320" cy="1234440"/>
+            <a:off x="1600200" y="4343400"/>
+            <a:ext cx="182880" cy="1188720"/>
           </a:xfrm>
           <a:prstGeom prst="rect">
             <a:avLst/>
@@ -15831,8 +15831,8 @@
         </p:nvSpPr>
         <p:spPr>
           <a:xfrm>
-            <a:off x="548640" y="4544568"/>
-            <a:ext cx="2103120" cy="640080"/>
+            <a:off x="548640" y="4453128"/>
+            <a:ext cx="1234440" cy="594360"/>
           </a:xfrm>
           <a:prstGeom prst="rect">
             <a:avLst/>
@@ -15848,7 +15848,7 @@
               <a:buNone/>
             </a:pPr>
             <a:r>
-              <a:rPr lang="en-US" sz="3400" b="1" dirty="0">
+              <a:rPr lang="en-US" sz="2600" b="1" dirty="0">
                 <a:solidFill>
                   <a:srgbClr val="FFFFFF"/>
                 </a:solidFill>
@@ -15858,7 +15858,7 @@
               </a:rPr>
               <a:t>4</a:t>
             </a:r>
-            <a:endParaRPr lang="en-US" sz="3400" dirty="0"/>
+            <a:endParaRPr lang="en-US" sz="2600" dirty="0"/>
           </a:p>
         </p:txBody>
       </p:sp>
@@ -15870,8 +15870,8 @@
         </p:nvSpPr>
         <p:spPr>
           <a:xfrm>
-            <a:off x="548640" y="5212080"/>
-            <a:ext cx="2103120" cy="320040"/>
+            <a:off x="548640" y="5093208"/>
+            <a:ext cx="1234440" cy="320040"/>
           </a:xfrm>
           <a:prstGeom prst="rect">
             <a:avLst/>
@@ -15887,7 +15887,7 @@
               <a:buNone/>
             </a:pPr>
             <a:r>
-              <a:rPr lang="en-US" sz="1000" b="1" spc="150" kern="0" dirty="0">
+              <a:rPr lang="en-US" sz="800" b="1" spc="100" kern="0" dirty="0">
                 <a:solidFill>
                   <a:srgbClr val="FFFFFF"/>
                 </a:solidFill>
@@ -15897,7 +15897,7 @@
               </a:rPr>
               <a:t>RISQUE ÉLEVÉ</a:t>
             </a:r>
-            <a:endParaRPr lang="en-US" sz="1000" dirty="0"/>
+            <a:endParaRPr lang="en-US" sz="800" dirty="0"/>
           </a:p>
         </p:txBody>
       </p:sp>
@@ -15909,8 +15909,8 @@
         </p:nvSpPr>
         <p:spPr>
           <a:xfrm>
-            <a:off x="2926080" y="4572000"/>
-            <a:ext cx="6035040" cy="365760"/>
+            <a:off x="1920240" y="4434840"/>
+            <a:ext cx="2651760" cy="548640"/>
           </a:xfrm>
           <a:prstGeom prst="rect">
             <a:avLst/>
@@ -15926,7 +15926,7 @@
               <a:buNone/>
             </a:pPr>
             <a:r>
-              <a:rPr lang="en-US" sz="1350" b="1" dirty="0">
+              <a:rPr lang="en-US" sz="1050" b="1" dirty="0">
                 <a:solidFill>
                   <a:srgbClr val="0A2A5E"/>
                 </a:solidFill>
@@ -15936,7 +15936,7 @@
               </a:rPr>
               <a:t>Biélorussie · Corée du Nord · Birmanie · Russie</a:t>
             </a:r>
-            <a:endParaRPr lang="en-US" sz="1350" dirty="0"/>
+            <a:endParaRPr lang="en-US" sz="1050" dirty="0"/>
           </a:p>
         </p:txBody>
       </p:sp>
@@ -15948,8 +15948,8 @@
         </p:nvSpPr>
         <p:spPr>
           <a:xfrm>
-            <a:off x="2926080" y="4983480"/>
-            <a:ext cx="6035040" cy="640080"/>
+            <a:off x="1920240" y="5001768"/>
+            <a:ext cx="2651760" cy="502920"/>
           </a:xfrm>
           <a:prstGeom prst="rect">
             <a:avLst/>
@@ -15965,7 +15965,7 @@
               <a:buNone/>
             </a:pPr>
             <a:r>
-              <a:rPr lang="en-US" sz="1200" dirty="0">
+              <a:rPr lang="en-US" sz="950" dirty="0">
                 <a:solidFill>
                   <a:srgbClr val="5B6B7F"/>
                 </a:solidFill>
@@ -15975,7 +15975,7 @@
               </a:rPr>
               <a:t>Vigilance renforcée et contrôles accrus.</a:t>
             </a:r>
-            <a:endParaRPr lang="en-US" sz="1200" dirty="0"/>
+            <a:endParaRPr lang="en-US" sz="950" dirty="0"/>
           </a:p>
         </p:txBody>
       </p:sp>
@@ -15987,8 +15987,8 @@
         </p:nvSpPr>
         <p:spPr>
           <a:xfrm>
-            <a:off x="9418320" y="4617720"/>
-            <a:ext cx="2011680" cy="274320"/>
+            <a:off x="4617720" y="4526280"/>
+            <a:ext cx="640080" cy="228600"/>
           </a:xfrm>
           <a:prstGeom prst="rect">
             <a:avLst/>
@@ -16004,7 +16004,7 @@
               <a:buNone/>
             </a:pPr>
             <a:r>
-              <a:rPr lang="en-US" sz="1000" spc="150" kern="0" dirty="0">
+              <a:rPr lang="en-US" sz="800" dirty="0">
                 <a:solidFill>
                   <a:srgbClr val="8A98A8"/>
                 </a:solidFill>
@@ -16012,9 +16012,9 @@
                 <a:ea typeface="Calibri" pitchFamily="34" charset="-122"/>
                 <a:cs typeface="Calibri" pitchFamily="34" charset="-120"/>
               </a:rPr>
-              <a:t>Contrôles</a:t>
-            </a:r>
-            <a:endParaRPr lang="en-US" sz="1000" dirty="0"/>
+              <a:t>contrôles</a:t>
+            </a:r>
+            <a:endParaRPr lang="en-US" sz="800" dirty="0"/>
           </a:p>
         </p:txBody>
       </p:sp>
@@ -16026,8 +16026,8 @@
         </p:nvSpPr>
         <p:spPr>
           <a:xfrm>
-            <a:off x="9418320" y="4846320"/>
-            <a:ext cx="2011680" cy="640080"/>
+            <a:off x="4572000" y="4754880"/>
+            <a:ext cx="731520" cy="548640"/>
           </a:xfrm>
           <a:prstGeom prst="rect">
             <a:avLst/>
@@ -16043,7 +16043,7 @@
               <a:buNone/>
             </a:pPr>
             <a:r>
-              <a:rPr lang="en-US" sz="2600" b="1" dirty="0">
+              <a:rPr lang="en-US" sz="2000" b="1" dirty="0">
                 <a:solidFill>
                   <a:srgbClr val="D0313B"/>
                 </a:solidFill>
@@ -16053,19 +16053,308 @@
               </a:rPr>
               <a:t>9 %</a:t>
             </a:r>
-            <a:endParaRPr lang="en-US" sz="2600" dirty="0"/>
-          </a:p>
-        </p:txBody>
-      </p:sp>
-      <p:sp>
-        <p:nvSpPr>
-          <p:cNvPr id="34" name="Text 31"/>
-          <p:cNvSpPr txBox="1"/>
-          <p:nvPr/>
-        </p:nvSpPr>
-        <p:spPr>
-          <a:xfrm>
-            <a:off x="548640" y="5852160"/>
+            <a:endParaRPr lang="en-US" sz="2000" dirty="0"/>
+          </a:p>
+        </p:txBody>
+      </p:sp>
+      <p:sp>
+        <p:nvSpPr>
+          <p:cNvPr id="34" name="Shape 31"/>
+          <p:cNvSpPr/>
+          <p:nvPr/>
+        </p:nvSpPr>
+        <p:spPr>
+          <a:xfrm>
+            <a:off x="5532120" y="1691640"/>
+            <a:ext cx="6080760" cy="4114800"/>
+          </a:xfrm>
+          <a:prstGeom prst="roundRect">
+            <a:avLst>
+              <a:gd name="adj" fmla="val 1778"/>
+            </a:avLst>
+          </a:prstGeom>
+          <a:solidFill>
+            <a:srgbClr val="FFFFFF"/>
+          </a:solidFill>
+          <a:ln w="9525">
+            <a:solidFill>
+              <a:srgbClr val="D9E1EC"/>
+            </a:solidFill>
+            <a:prstDash val="solid"/>
+          </a:ln>
+          <a:effectLst>
+            <a:outerShdw sx="100000" sy="100000" kx="0" ky="0" algn="bl" rotWithShape="0" blurRad="50800" dist="12700" dir="5400000">
+              <a:srgbClr val="8AA0B4">
+                <a:alpha val="22000"/>
+              </a:srgbClr>
+            </a:outerShdw>
+          </a:effectLst>
+        </p:spPr>
+      </p:sp>
+      <p:pic>
+        <p:nvPicPr>
+          <p:cNvPr id="35" name="Image 1" descr="preencoded.png">    </p:cNvPr>
+          <p:cNvPicPr>
+            <a:picLocks noChangeAspect="1"/>
+          </p:cNvPicPr>
+          <p:nvPr/>
+        </p:nvPicPr>
+        <p:blipFill>
+          <a:blip r:embed="rId2"/>
+          <a:stretch>
+            <a:fillRect/>
+          </a:stretch>
+        </p:blipFill>
+        <p:spPr>
+          <a:xfrm>
+            <a:off x="5669280" y="1783080"/>
+            <a:ext cx="5806440" cy="2907792"/>
+          </a:xfrm>
+          <a:prstGeom prst="rect">
+            <a:avLst/>
+          </a:prstGeom>
+        </p:spPr>
+      </p:pic>
+      <p:sp>
+        <p:nvSpPr>
+          <p:cNvPr id="36" name="Shape 32"/>
+          <p:cNvSpPr/>
+          <p:nvPr/>
+        </p:nvSpPr>
+        <p:spPr>
+          <a:xfrm>
+            <a:off x="5806440" y="4937760"/>
+            <a:ext cx="201168" cy="201168"/>
+          </a:xfrm>
+          <a:prstGeom prst="ellipse">
+            <a:avLst/>
+          </a:prstGeom>
+          <a:solidFill>
+            <a:srgbClr val="1E8E5A"/>
+          </a:solidFill>
+          <a:ln w="12700">
+            <a:solidFill>
+              <a:srgbClr val="1E8E5A"/>
+            </a:solidFill>
+            <a:prstDash val="solid"/>
+          </a:ln>
+        </p:spPr>
+      </p:sp>
+      <p:sp>
+        <p:nvSpPr>
+          <p:cNvPr id="37" name="Text 33"/>
+          <p:cNvSpPr txBox="1"/>
+          <p:nvPr/>
+        </p:nvSpPr>
+        <p:spPr>
+          <a:xfrm>
+            <a:off x="6080760" y="4901184"/>
+            <a:ext cx="1554480" cy="274320"/>
+          </a:xfrm>
+          <a:prstGeom prst="rect">
+            <a:avLst/>
+          </a:prstGeom>
+          <a:noFill/>
+          <a:ln/>
+        </p:spPr>
+        <p:txBody>
+          <a:bodyPr wrap="square" lIns="0" tIns="0" rIns="0" bIns="0" rtlCol="0" anchor="ctr"/>
+          <a:lstStyle/>
+          <a:p>
+            <a:pPr indent="0" marL="0">
+              <a:buNone/>
+            </a:pPr>
+            <a:r>
+              <a:rPr lang="en-US" sz="1100" dirty="0">
+                <a:solidFill>
+                  <a:srgbClr val="1F2A3A"/>
+                </a:solidFill>
+                <a:latin typeface="Calibri" pitchFamily="34" charset="0"/>
+                <a:ea typeface="Calibri" pitchFamily="34" charset="-122"/>
+                <a:cs typeface="Calibri" pitchFamily="34" charset="-120"/>
+              </a:rPr>
+              <a:t>Risque faible</a:t>
+            </a:r>
+            <a:endParaRPr lang="en-US" sz="1100" dirty="0"/>
+          </a:p>
+        </p:txBody>
+      </p:sp>
+      <p:sp>
+        <p:nvSpPr>
+          <p:cNvPr id="38" name="Shape 34"/>
+          <p:cNvSpPr/>
+          <p:nvPr/>
+        </p:nvSpPr>
+        <p:spPr>
+          <a:xfrm>
+            <a:off x="7726680" y="4937760"/>
+            <a:ext cx="201168" cy="201168"/>
+          </a:xfrm>
+          <a:prstGeom prst="ellipse">
+            <a:avLst/>
+          </a:prstGeom>
+          <a:solidFill>
+            <a:srgbClr val="B7791F"/>
+          </a:solidFill>
+          <a:ln w="12700">
+            <a:solidFill>
+              <a:srgbClr val="B7791F"/>
+            </a:solidFill>
+            <a:prstDash val="solid"/>
+          </a:ln>
+        </p:spPr>
+      </p:sp>
+      <p:sp>
+        <p:nvSpPr>
+          <p:cNvPr id="39" name="Text 35"/>
+          <p:cNvSpPr txBox="1"/>
+          <p:nvPr/>
+        </p:nvSpPr>
+        <p:spPr>
+          <a:xfrm>
+            <a:off x="8001000" y="4901184"/>
+            <a:ext cx="1554480" cy="274320"/>
+          </a:xfrm>
+          <a:prstGeom prst="rect">
+            <a:avLst/>
+          </a:prstGeom>
+          <a:noFill/>
+          <a:ln/>
+        </p:spPr>
+        <p:txBody>
+          <a:bodyPr wrap="square" lIns="0" tIns="0" rIns="0" bIns="0" rtlCol="0" anchor="ctr"/>
+          <a:lstStyle/>
+          <a:p>
+            <a:pPr indent="0" marL="0">
+              <a:buNone/>
+            </a:pPr>
+            <a:r>
+              <a:rPr lang="en-US" sz="1100" dirty="0">
+                <a:solidFill>
+                  <a:srgbClr val="1F2A3A"/>
+                </a:solidFill>
+                <a:latin typeface="Calibri" pitchFamily="34" charset="0"/>
+                <a:ea typeface="Calibri" pitchFamily="34" charset="-122"/>
+                <a:cs typeface="Calibri" pitchFamily="34" charset="-120"/>
+              </a:rPr>
+              <a:t>Risque standard</a:t>
+            </a:r>
+            <a:endParaRPr lang="en-US" sz="1100" dirty="0"/>
+          </a:p>
+        </p:txBody>
+      </p:sp>
+      <p:sp>
+        <p:nvSpPr>
+          <p:cNvPr id="40" name="Shape 36"/>
+          <p:cNvSpPr/>
+          <p:nvPr/>
+        </p:nvSpPr>
+        <p:spPr>
+          <a:xfrm>
+            <a:off x="9646920" y="4937760"/>
+            <a:ext cx="201168" cy="201168"/>
+          </a:xfrm>
+          <a:prstGeom prst="ellipse">
+            <a:avLst/>
+          </a:prstGeom>
+          <a:solidFill>
+            <a:srgbClr val="D0313B"/>
+          </a:solidFill>
+          <a:ln w="12700">
+            <a:solidFill>
+              <a:srgbClr val="D0313B"/>
+            </a:solidFill>
+            <a:prstDash val="solid"/>
+          </a:ln>
+        </p:spPr>
+      </p:sp>
+      <p:sp>
+        <p:nvSpPr>
+          <p:cNvPr id="41" name="Text 37"/>
+          <p:cNvSpPr txBox="1"/>
+          <p:nvPr/>
+        </p:nvSpPr>
+        <p:spPr>
+          <a:xfrm>
+            <a:off x="9921240" y="4901184"/>
+            <a:ext cx="1554480" cy="274320"/>
+          </a:xfrm>
+          <a:prstGeom prst="rect">
+            <a:avLst/>
+          </a:prstGeom>
+          <a:noFill/>
+          <a:ln/>
+        </p:spPr>
+        <p:txBody>
+          <a:bodyPr wrap="square" lIns="0" tIns="0" rIns="0" bIns="0" rtlCol="0" anchor="ctr"/>
+          <a:lstStyle/>
+          <a:p>
+            <a:pPr indent="0" marL="0">
+              <a:buNone/>
+            </a:pPr>
+            <a:r>
+              <a:rPr lang="en-US" sz="1100" dirty="0">
+                <a:solidFill>
+                  <a:srgbClr val="1F2A3A"/>
+                </a:solidFill>
+                <a:latin typeface="Calibri" pitchFamily="34" charset="0"/>
+                <a:ea typeface="Calibri" pitchFamily="34" charset="-122"/>
+                <a:cs typeface="Calibri" pitchFamily="34" charset="-120"/>
+              </a:rPr>
+              <a:t>Risque élevé</a:t>
+            </a:r>
+            <a:endParaRPr lang="en-US" sz="1100" dirty="0"/>
+          </a:p>
+        </p:txBody>
+      </p:sp>
+      <p:sp>
+        <p:nvSpPr>
+          <p:cNvPr id="42" name="Text 38"/>
+          <p:cNvSpPr txBox="1"/>
+          <p:nvPr/>
+        </p:nvSpPr>
+        <p:spPr>
+          <a:xfrm>
+            <a:off x="5669280" y="5257800"/>
+            <a:ext cx="5806440" cy="457200"/>
+          </a:xfrm>
+          <a:prstGeom prst="rect">
+            <a:avLst/>
+          </a:prstGeom>
+          <a:noFill/>
+          <a:ln/>
+        </p:spPr>
+        <p:txBody>
+          <a:bodyPr wrap="square" lIns="0" tIns="0" rIns="0" bIns="0" rtlCol="0" anchor="t"/>
+          <a:lstStyle/>
+          <a:p>
+            <a:pPr indent="0" marL="0">
+              <a:buNone/>
+            </a:pPr>
+            <a:r>
+              <a:rPr lang="en-US" sz="950" i="1" dirty="0">
+                <a:solidFill>
+                  <a:srgbClr val="8A98A8"/>
+                </a:solidFill>
+                <a:latin typeface="Calibri" pitchFamily="34" charset="0"/>
+                <a:ea typeface="Calibri" pitchFamily="34" charset="-122"/>
+                <a:cs typeface="Calibri" pitchFamily="34" charset="-120"/>
+              </a:rPr>
+              <a:t>Carte indicative d'après le règlement d'exécution (UE) 2025/1093 (liste du 22/05/2025) — à contrôler sur l'annexe officielle avant diffusion.</a:t>
+            </a:r>
+            <a:endParaRPr lang="en-US" sz="950" dirty="0"/>
+          </a:p>
+        </p:txBody>
+      </p:sp>
+      <p:sp>
+        <p:nvSpPr>
+          <p:cNvPr id="43" name="Text 39"/>
+          <p:cNvSpPr txBox="1"/>
+          <p:nvPr/>
+        </p:nvSpPr>
+        <p:spPr>
+          <a:xfrm>
+            <a:off x="548640" y="5897880"/>
             <a:ext cx="11064240" cy="457200"/>
           </a:xfrm>
           <a:prstGeom prst="rect">
@@ -16302,7 +16591,7 @@
                 <a:ea typeface="Calibri" pitchFamily="34" charset="-122"/>
                 <a:cs typeface="Calibri" pitchFamily="34" charset="-120"/>
               </a:rPr>
-              <a:t>Le déroulé du webinaire — 1 h 30, une introduction et quatre parties.</a:t>
+              <a:t>Le déroulé du webinaire : une introduction et quatre parties.</a:t>
             </a:r>
             <a:endParaRPr lang="en-US" sz="1400" dirty="0"/>
           </a:p>
@@ -16417,7 +16706,7 @@
         <p:spPr>
           <a:xfrm>
             <a:off x="1737360" y="1691640"/>
-            <a:ext cx="7772400" cy="347472"/>
+            <a:ext cx="9601200" cy="347472"/>
           </a:xfrm>
           <a:prstGeom prst="rect">
             <a:avLst/>
@@ -16456,7 +16745,7 @@
         <p:spPr>
           <a:xfrm>
             <a:off x="1737360" y="2039112"/>
-            <a:ext cx="7863840" cy="320040"/>
+            <a:ext cx="9601200" cy="320040"/>
           </a:xfrm>
           <a:prstGeom prst="rect">
             <a:avLst/>
@@ -16489,72 +16778,6 @@
       <p:sp>
         <p:nvSpPr>
           <p:cNvPr id="12" name="Shape 9"/>
-          <p:cNvSpPr/>
-          <p:nvPr/>
-        </p:nvSpPr>
-        <p:spPr>
-          <a:xfrm>
-            <a:off x="9966960" y="1828800"/>
-            <a:ext cx="1417320" cy="347472"/>
-          </a:xfrm>
-          <a:prstGeom prst="roundRect">
-            <a:avLst>
-              <a:gd name="adj" fmla="val 131579"/>
-            </a:avLst>
-          </a:prstGeom>
-          <a:solidFill>
-            <a:srgbClr val="E8EFFA"/>
-          </a:solidFill>
-          <a:ln w="12700">
-            <a:solidFill>
-              <a:srgbClr val="E8EFFA"/>
-            </a:solidFill>
-            <a:prstDash val="solid"/>
-          </a:ln>
-        </p:spPr>
-      </p:sp>
-      <p:sp>
-        <p:nvSpPr>
-          <p:cNvPr id="13" name="Text 10"/>
-          <p:cNvSpPr txBox="1"/>
-          <p:nvPr/>
-        </p:nvSpPr>
-        <p:spPr>
-          <a:xfrm>
-            <a:off x="9966960" y="1828800"/>
-            <a:ext cx="1417320" cy="347472"/>
-          </a:xfrm>
-          <a:prstGeom prst="rect">
-            <a:avLst/>
-          </a:prstGeom>
-          <a:noFill/>
-          <a:ln/>
-        </p:spPr>
-        <p:txBody>
-          <a:bodyPr wrap="square" lIns="0" tIns="0" rIns="0" bIns="0" rtlCol="0" anchor="ctr"/>
-          <a:lstStyle/>
-          <a:p>
-            <a:pPr algn="ctr" indent="0" marL="0">
-              <a:buNone/>
-            </a:pPr>
-            <a:r>
-              <a:rPr lang="en-US" sz="1100" b="1" dirty="0">
-                <a:solidFill>
-                  <a:srgbClr val="00439A"/>
-                </a:solidFill>
-                <a:latin typeface="Calibri" pitchFamily="34" charset="0"/>
-                <a:ea typeface="Calibri" pitchFamily="34" charset="-122"/>
-                <a:cs typeface="Calibri" pitchFamily="34" charset="-120"/>
-              </a:rPr>
-              <a:t>10 min</a:t>
-            </a:r>
-            <a:endParaRPr lang="en-US" sz="1100" dirty="0"/>
-          </a:p>
-        </p:txBody>
-      </p:sp>
-      <p:sp>
-        <p:nvSpPr>
-          <p:cNvPr id="14" name="Shape 11"/>
           <p:cNvSpPr/>
           <p:nvPr/>
         </p:nvSpPr>
@@ -16588,7 +16811,7 @@
       </p:sp>
       <p:sp>
         <p:nvSpPr>
-          <p:cNvPr id="15" name="Shape 12"/>
+          <p:cNvPr id="13" name="Shape 10"/>
           <p:cNvSpPr/>
           <p:nvPr/>
         </p:nvSpPr>
@@ -16615,7 +16838,7 @@
       </p:sp>
       <p:sp>
         <p:nvSpPr>
-          <p:cNvPr id="16" name="Text 13"/>
+          <p:cNvPr id="14" name="Text 11"/>
           <p:cNvSpPr txBox="1"/>
           <p:nvPr/>
         </p:nvSpPr>
@@ -16654,14 +16877,14 @@
       </p:sp>
       <p:sp>
         <p:nvSpPr>
-          <p:cNvPr id="17" name="Text 14"/>
+          <p:cNvPr id="15" name="Text 12"/>
           <p:cNvSpPr txBox="1"/>
           <p:nvPr/>
         </p:nvSpPr>
         <p:spPr>
           <a:xfrm>
             <a:off x="1737360" y="2624328"/>
-            <a:ext cx="7772400" cy="347472"/>
+            <a:ext cx="9601200" cy="347472"/>
           </a:xfrm>
           <a:prstGeom prst="rect">
             <a:avLst/>
@@ -16693,14 +16916,14 @@
       </p:sp>
       <p:sp>
         <p:nvSpPr>
-          <p:cNvPr id="18" name="Text 15"/>
+          <p:cNvPr id="16" name="Text 13"/>
           <p:cNvSpPr txBox="1"/>
           <p:nvPr/>
         </p:nvSpPr>
         <p:spPr>
           <a:xfrm>
             <a:off x="1737360" y="2971800"/>
-            <a:ext cx="7863840" cy="320040"/>
+            <a:ext cx="9601200" cy="320040"/>
           </a:xfrm>
           <a:prstGeom prst="rect">
             <a:avLst/>
@@ -16732,73 +16955,7 @@
       </p:sp>
       <p:sp>
         <p:nvSpPr>
-          <p:cNvPr id="19" name="Shape 16"/>
-          <p:cNvSpPr/>
-          <p:nvPr/>
-        </p:nvSpPr>
-        <p:spPr>
-          <a:xfrm>
-            <a:off x="9966960" y="2761488"/>
-            <a:ext cx="1417320" cy="347472"/>
-          </a:xfrm>
-          <a:prstGeom prst="roundRect">
-            <a:avLst>
-              <a:gd name="adj" fmla="val 131579"/>
-            </a:avLst>
-          </a:prstGeom>
-          <a:solidFill>
-            <a:srgbClr val="E8EFFA"/>
-          </a:solidFill>
-          <a:ln w="12700">
-            <a:solidFill>
-              <a:srgbClr val="E8EFFA"/>
-            </a:solidFill>
-            <a:prstDash val="solid"/>
-          </a:ln>
-        </p:spPr>
-      </p:sp>
-      <p:sp>
-        <p:nvSpPr>
-          <p:cNvPr id="20" name="Text 17"/>
-          <p:cNvSpPr txBox="1"/>
-          <p:nvPr/>
-        </p:nvSpPr>
-        <p:spPr>
-          <a:xfrm>
-            <a:off x="9966960" y="2761488"/>
-            <a:ext cx="1417320" cy="347472"/>
-          </a:xfrm>
-          <a:prstGeom prst="rect">
-            <a:avLst/>
-          </a:prstGeom>
-          <a:noFill/>
-          <a:ln/>
-        </p:spPr>
-        <p:txBody>
-          <a:bodyPr wrap="square" lIns="0" tIns="0" rIns="0" bIns="0" rtlCol="0" anchor="ctr"/>
-          <a:lstStyle/>
-          <a:p>
-            <a:pPr algn="ctr" indent="0" marL="0">
-              <a:buNone/>
-            </a:pPr>
-            <a:r>
-              <a:rPr lang="en-US" sz="1100" b="1" dirty="0">
-                <a:solidFill>
-                  <a:srgbClr val="00439A"/>
-                </a:solidFill>
-                <a:latin typeface="Calibri" pitchFamily="34" charset="0"/>
-                <a:ea typeface="Calibri" pitchFamily="34" charset="-122"/>
-                <a:cs typeface="Calibri" pitchFamily="34" charset="-120"/>
-              </a:rPr>
-              <a:t>20 min</a:t>
-            </a:r>
-            <a:endParaRPr lang="en-US" sz="1100" dirty="0"/>
-          </a:p>
-        </p:txBody>
-      </p:sp>
-      <p:sp>
-        <p:nvSpPr>
-          <p:cNvPr id="21" name="Shape 18"/>
+          <p:cNvPr id="17" name="Shape 14"/>
           <p:cNvSpPr/>
           <p:nvPr/>
         </p:nvSpPr>
@@ -16832,7 +16989,7 @@
       </p:sp>
       <p:sp>
         <p:nvSpPr>
-          <p:cNvPr id="22" name="Shape 19"/>
+          <p:cNvPr id="18" name="Shape 15"/>
           <p:cNvSpPr/>
           <p:nvPr/>
         </p:nvSpPr>
@@ -16859,7 +17016,7 @@
       </p:sp>
       <p:sp>
         <p:nvSpPr>
-          <p:cNvPr id="23" name="Text 20"/>
+          <p:cNvPr id="19" name="Text 16"/>
           <p:cNvSpPr txBox="1"/>
           <p:nvPr/>
         </p:nvSpPr>
@@ -16898,14 +17055,14 @@
       </p:sp>
       <p:sp>
         <p:nvSpPr>
-          <p:cNvPr id="24" name="Text 21"/>
+          <p:cNvPr id="20" name="Text 17"/>
           <p:cNvSpPr txBox="1"/>
           <p:nvPr/>
         </p:nvSpPr>
         <p:spPr>
           <a:xfrm>
             <a:off x="1737360" y="3557016"/>
-            <a:ext cx="7772400" cy="347472"/>
+            <a:ext cx="9601200" cy="347472"/>
           </a:xfrm>
           <a:prstGeom prst="rect">
             <a:avLst/>
@@ -16937,14 +17094,14 @@
       </p:sp>
       <p:sp>
         <p:nvSpPr>
-          <p:cNvPr id="25" name="Text 22"/>
+          <p:cNvPr id="21" name="Text 18"/>
           <p:cNvSpPr txBox="1"/>
           <p:nvPr/>
         </p:nvSpPr>
         <p:spPr>
           <a:xfrm>
             <a:off x="1737360" y="3904488"/>
-            <a:ext cx="7863840" cy="320040"/>
+            <a:ext cx="9601200" cy="320040"/>
           </a:xfrm>
           <a:prstGeom prst="rect">
             <a:avLst/>
@@ -16976,73 +17133,7 @@
       </p:sp>
       <p:sp>
         <p:nvSpPr>
-          <p:cNvPr id="26" name="Shape 23"/>
-          <p:cNvSpPr/>
-          <p:nvPr/>
-        </p:nvSpPr>
-        <p:spPr>
-          <a:xfrm>
-            <a:off x="9966960" y="3694176"/>
-            <a:ext cx="1417320" cy="347472"/>
-          </a:xfrm>
-          <a:prstGeom prst="roundRect">
-            <a:avLst>
-              <a:gd name="adj" fmla="val 131579"/>
-            </a:avLst>
-          </a:prstGeom>
-          <a:solidFill>
-            <a:srgbClr val="E8EFFA"/>
-          </a:solidFill>
-          <a:ln w="12700">
-            <a:solidFill>
-              <a:srgbClr val="E8EFFA"/>
-            </a:solidFill>
-            <a:prstDash val="solid"/>
-          </a:ln>
-        </p:spPr>
-      </p:sp>
-      <p:sp>
-        <p:nvSpPr>
-          <p:cNvPr id="27" name="Text 24"/>
-          <p:cNvSpPr txBox="1"/>
-          <p:nvPr/>
-        </p:nvSpPr>
-        <p:spPr>
-          <a:xfrm>
-            <a:off x="9966960" y="3694176"/>
-            <a:ext cx="1417320" cy="347472"/>
-          </a:xfrm>
-          <a:prstGeom prst="rect">
-            <a:avLst/>
-          </a:prstGeom>
-          <a:noFill/>
-          <a:ln/>
-        </p:spPr>
-        <p:txBody>
-          <a:bodyPr wrap="square" lIns="0" tIns="0" rIns="0" bIns="0" rtlCol="0" anchor="ctr"/>
-          <a:lstStyle/>
-          <a:p>
-            <a:pPr algn="ctr" indent="0" marL="0">
-              <a:buNone/>
-            </a:pPr>
-            <a:r>
-              <a:rPr lang="en-US" sz="1100" b="1" dirty="0">
-                <a:solidFill>
-                  <a:srgbClr val="00439A"/>
-                </a:solidFill>
-                <a:latin typeface="Calibri" pitchFamily="34" charset="0"/>
-                <a:ea typeface="Calibri" pitchFamily="34" charset="-122"/>
-                <a:cs typeface="Calibri" pitchFamily="34" charset="-120"/>
-              </a:rPr>
-              <a:t>30 min</a:t>
-            </a:r>
-            <a:endParaRPr lang="en-US" sz="1100" dirty="0"/>
-          </a:p>
-        </p:txBody>
-      </p:sp>
-      <p:sp>
-        <p:nvSpPr>
-          <p:cNvPr id="28" name="Shape 25"/>
+          <p:cNvPr id="22" name="Shape 19"/>
           <p:cNvSpPr/>
           <p:nvPr/>
         </p:nvSpPr>
@@ -17076,7 +17167,7 @@
       </p:sp>
       <p:sp>
         <p:nvSpPr>
-          <p:cNvPr id="29" name="Shape 26"/>
+          <p:cNvPr id="23" name="Shape 20"/>
           <p:cNvSpPr/>
           <p:nvPr/>
         </p:nvSpPr>
@@ -17103,7 +17194,7 @@
       </p:sp>
       <p:sp>
         <p:nvSpPr>
-          <p:cNvPr id="30" name="Text 27"/>
+          <p:cNvPr id="24" name="Text 21"/>
           <p:cNvSpPr txBox="1"/>
           <p:nvPr/>
         </p:nvSpPr>
@@ -17142,14 +17233,14 @@
       </p:sp>
       <p:sp>
         <p:nvSpPr>
-          <p:cNvPr id="31" name="Text 28"/>
+          <p:cNvPr id="25" name="Text 22"/>
           <p:cNvSpPr txBox="1"/>
           <p:nvPr/>
         </p:nvSpPr>
         <p:spPr>
           <a:xfrm>
             <a:off x="1737360" y="4489704"/>
-            <a:ext cx="7772400" cy="347472"/>
+            <a:ext cx="9601200" cy="347472"/>
           </a:xfrm>
           <a:prstGeom prst="rect">
             <a:avLst/>
@@ -17181,14 +17272,14 @@
       </p:sp>
       <p:sp>
         <p:nvSpPr>
-          <p:cNvPr id="32" name="Text 29"/>
+          <p:cNvPr id="26" name="Text 23"/>
           <p:cNvSpPr txBox="1"/>
           <p:nvPr/>
         </p:nvSpPr>
         <p:spPr>
           <a:xfrm>
             <a:off x="1737360" y="4837176"/>
-            <a:ext cx="7863840" cy="320040"/>
+            <a:ext cx="9601200" cy="320040"/>
           </a:xfrm>
           <a:prstGeom prst="rect">
             <a:avLst/>
@@ -17220,73 +17311,7 @@
       </p:sp>
       <p:sp>
         <p:nvSpPr>
-          <p:cNvPr id="33" name="Shape 30"/>
-          <p:cNvSpPr/>
-          <p:nvPr/>
-        </p:nvSpPr>
-        <p:spPr>
-          <a:xfrm>
-            <a:off x="9966960" y="4626864"/>
-            <a:ext cx="1417320" cy="347472"/>
-          </a:xfrm>
-          <a:prstGeom prst="roundRect">
-            <a:avLst>
-              <a:gd name="adj" fmla="val 131579"/>
-            </a:avLst>
-          </a:prstGeom>
-          <a:solidFill>
-            <a:srgbClr val="E8EFFA"/>
-          </a:solidFill>
-          <a:ln w="12700">
-            <a:solidFill>
-              <a:srgbClr val="E8EFFA"/>
-            </a:solidFill>
-            <a:prstDash val="solid"/>
-          </a:ln>
-        </p:spPr>
-      </p:sp>
-      <p:sp>
-        <p:nvSpPr>
-          <p:cNvPr id="34" name="Text 31"/>
-          <p:cNvSpPr txBox="1"/>
-          <p:nvPr/>
-        </p:nvSpPr>
-        <p:spPr>
-          <a:xfrm>
-            <a:off x="9966960" y="4626864"/>
-            <a:ext cx="1417320" cy="347472"/>
-          </a:xfrm>
-          <a:prstGeom prst="rect">
-            <a:avLst/>
-          </a:prstGeom>
-          <a:noFill/>
-          <a:ln/>
-        </p:spPr>
-        <p:txBody>
-          <a:bodyPr wrap="square" lIns="0" tIns="0" rIns="0" bIns="0" rtlCol="0" anchor="ctr"/>
-          <a:lstStyle/>
-          <a:p>
-            <a:pPr algn="ctr" indent="0" marL="0">
-              <a:buNone/>
-            </a:pPr>
-            <a:r>
-              <a:rPr lang="en-US" sz="1100" b="1" dirty="0">
-                <a:solidFill>
-                  <a:srgbClr val="00439A"/>
-                </a:solidFill>
-                <a:latin typeface="Calibri" pitchFamily="34" charset="0"/>
-                <a:ea typeface="Calibri" pitchFamily="34" charset="-122"/>
-                <a:cs typeface="Calibri" pitchFamily="34" charset="-120"/>
-              </a:rPr>
-              <a:t>20 min</a:t>
-            </a:r>
-            <a:endParaRPr lang="en-US" sz="1100" dirty="0"/>
-          </a:p>
-        </p:txBody>
-      </p:sp>
-      <p:sp>
-        <p:nvSpPr>
-          <p:cNvPr id="35" name="Shape 32"/>
+          <p:cNvPr id="27" name="Shape 24"/>
           <p:cNvSpPr/>
           <p:nvPr/>
         </p:nvSpPr>
@@ -17320,7 +17345,7 @@
       </p:sp>
       <p:sp>
         <p:nvSpPr>
-          <p:cNvPr id="36" name="Shape 33"/>
+          <p:cNvPr id="28" name="Shape 25"/>
           <p:cNvSpPr/>
           <p:nvPr/>
         </p:nvSpPr>
@@ -17347,7 +17372,7 @@
       </p:sp>
       <p:sp>
         <p:nvSpPr>
-          <p:cNvPr id="37" name="Text 34"/>
+          <p:cNvPr id="29" name="Text 26"/>
           <p:cNvSpPr txBox="1"/>
           <p:nvPr/>
         </p:nvSpPr>
@@ -17386,14 +17411,14 @@
       </p:sp>
       <p:sp>
         <p:nvSpPr>
-          <p:cNvPr id="38" name="Text 35"/>
+          <p:cNvPr id="30" name="Text 27"/>
           <p:cNvSpPr txBox="1"/>
           <p:nvPr/>
         </p:nvSpPr>
         <p:spPr>
           <a:xfrm>
             <a:off x="1737360" y="5422392"/>
-            <a:ext cx="7772400" cy="347472"/>
+            <a:ext cx="9601200" cy="347472"/>
           </a:xfrm>
           <a:prstGeom prst="rect">
             <a:avLst/>
@@ -17425,14 +17450,14 @@
       </p:sp>
       <p:sp>
         <p:nvSpPr>
-          <p:cNvPr id="39" name="Text 36"/>
+          <p:cNvPr id="31" name="Text 28"/>
           <p:cNvSpPr txBox="1"/>
           <p:nvPr/>
         </p:nvSpPr>
         <p:spPr>
           <a:xfrm>
             <a:off x="1737360" y="5769864"/>
-            <a:ext cx="7863840" cy="320040"/>
+            <a:ext cx="9601200" cy="320040"/>
           </a:xfrm>
           <a:prstGeom prst="rect">
             <a:avLst/>
@@ -17459,72 +17484,6 @@
               <a:t>Risques &amp; sanctions · leviers · feuille de route · quiz</a:t>
             </a:r>
             <a:endParaRPr lang="en-US" sz="1150" dirty="0"/>
-          </a:p>
-        </p:txBody>
-      </p:sp>
-      <p:sp>
-        <p:nvSpPr>
-          <p:cNvPr id="40" name="Shape 37"/>
-          <p:cNvSpPr/>
-          <p:nvPr/>
-        </p:nvSpPr>
-        <p:spPr>
-          <a:xfrm>
-            <a:off x="9966960" y="5559552"/>
-            <a:ext cx="1417320" cy="347472"/>
-          </a:xfrm>
-          <a:prstGeom prst="roundRect">
-            <a:avLst>
-              <a:gd name="adj" fmla="val 131579"/>
-            </a:avLst>
-          </a:prstGeom>
-          <a:solidFill>
-            <a:srgbClr val="E8EFFA"/>
-          </a:solidFill>
-          <a:ln w="12700">
-            <a:solidFill>
-              <a:srgbClr val="E8EFFA"/>
-            </a:solidFill>
-            <a:prstDash val="solid"/>
-          </a:ln>
-        </p:spPr>
-      </p:sp>
-      <p:sp>
-        <p:nvSpPr>
-          <p:cNvPr id="41" name="Text 38"/>
-          <p:cNvSpPr txBox="1"/>
-          <p:nvPr/>
-        </p:nvSpPr>
-        <p:spPr>
-          <a:xfrm>
-            <a:off x="9966960" y="5559552"/>
-            <a:ext cx="1417320" cy="347472"/>
-          </a:xfrm>
-          <a:prstGeom prst="rect">
-            <a:avLst/>
-          </a:prstGeom>
-          <a:noFill/>
-          <a:ln/>
-        </p:spPr>
-        <p:txBody>
-          <a:bodyPr wrap="square" lIns="0" tIns="0" rIns="0" bIns="0" rtlCol="0" anchor="ctr"/>
-          <a:lstStyle/>
-          <a:p>
-            <a:pPr algn="ctr" indent="0" marL="0">
-              <a:buNone/>
-            </a:pPr>
-            <a:r>
-              <a:rPr lang="en-US" sz="1100" b="1" dirty="0">
-                <a:solidFill>
-                  <a:srgbClr val="00439A"/>
-                </a:solidFill>
-                <a:latin typeface="Calibri" pitchFamily="34" charset="0"/>
-                <a:ea typeface="Calibri" pitchFamily="34" charset="-122"/>
-                <a:cs typeface="Calibri" pitchFamily="34" charset="-120"/>
-              </a:rPr>
-              <a:t>10 min</a:t>
-            </a:r>
-            <a:endParaRPr lang="en-US" sz="1100" dirty="0"/>
           </a:p>
         </p:txBody>
       </p:sp>

</xml_diff>